<commit_message>
Emphasize automatic background execution in Kopi pitch
</commit_message>
<xml_diff>
--- a/docs/presentation/Kopi-Hackathon-Pitch.pptx
+++ b/docs/presentation/Kopi-Hackathon-Pitch.pptx
@@ -140,7 +140,7 @@
                 <a:ea typeface="Segoe UI"/>
                 <a:cs typeface="Segoe UI"/>
               </a:rPr>
-              <a:t xml:space="preserve">Kopi is a local AI assistant that learns a supported browser task from a demonstration. The idea started with something I kept doing myself: logging into university and going through verification every day.</a:t>
+              <a:t xml:space="preserve">Kopi is designed to handle repeated browser work in the background. The idea started with something I kept doing myself: logging into university and going through verification every day. Once a supported verification workflow is learned and enabled, Kopi can recognise a matching challenge and execute it automatically.</a:t>
             </a:r>
             <a:endParaRPr lang="en-GB" sz="1200" b="0"/>
           </a:p>
@@ -513,7 +513,7 @@
                 <a:ea typeface="Segoe UI"/>
                 <a:cs typeface="Segoe UI"/>
               </a:rPr>
-              <a:t xml:space="preserve">My first thought was to automate that login routine. But a script written for one university page would only solve that one case. The more useful idea was to let the user show a task, then use AI to understand which steps stay the same and which information changes. The login was the starting point. Kopi became a way to teach other supported browser routines through a demonstration.</a:t>
+              <a:t xml:space="preserve">My first thought was to automate that login routine. But a script written for one university page would only solve that one case. The wider idea was a local assistant that recognises repeated browser work and handles it in the background. It should understand which steps stay the same and which information changes, so I can carry on with my day. Current automatic execution covers explicitly enabled learned verification workflows. Broader background learning and automation remain the product direction.</a:t>
             </a:r>
             <a:endParaRPr lang="en-GB" sz="1200" b="0"/>
           </a:p>
@@ -709,7 +709,7 @@
                 <a:ea typeface="Segoe UI"/>
                 <a:cs typeface="Segoe UI"/>
               </a:rPr>
-              <a:t xml:space="preserve">I start recording and complete a browser task. The extension captures selected actions and bounded page evidence. Gemma uses that demonstration to propose a workflow, identify changing inputs and ask about missing details. I review the proposal, answer questions and save it. Kopi can then use the saved workflow on a supported new page or challenge with fresh inputs. Normal workflows ask for run approval. For the supported fresh-code workflow, I can explicitly enable automatic execution once. A demonstration starts the process, but review is still part of it.</a:t>
+              <a:t xml:space="preserve">Kopi stays running with the paired browser extension. With page monitoring enabled, it receives page context and uses local Gemma to match that context to an approved learned workflow. When I reach a matching new verification challenge, Kopi runs the enabled workflow automatically, transfers a fresh code and checks the result. I do not have to open the app, start a recording or approve every repeat. Setup and enablement happen beforehand. Current automatic execution is scoped to supported fresh-value workflows. Ordinary workflows still require approval, and fully passive learning of arbitrary routines is not implemented.</a:t>
             </a:r>
             <a:endParaRPr lang="en-GB" sz="1200" b="0"/>
           </a:p>
@@ -886,7 +886,7 @@
                 <a:ea typeface="Segoe UI"/>
                 <a:cs typeface="Segoe UI"/>
               </a:rPr>
-              <a:t xml:space="preserve">This is the workflow I want Kopi to take over after I teach and enable it. A new university challenge requests a new code. Kopi looks in the demonstrated messaging conversation for a new matching message, transfers the code, submits it and checks for a separate success state. The code changes each time, so copying the old demonstrated value would be wrong. The implementation therefore checks freshness, source identity and destination identity, and stops if the new message is stale, missing or ambiguous. The browser tests exercise this flow on test pages. Real WhatsApp and university accounts still need validation.</a:t>
+              <a:t xml:space="preserve">After initial setup and enablement, reaching a matching new university challenge is the trigger. Kopi detects the page context in the background, requests a fresh code, finds the new matching message in the approved conversation, transfers the code, submits it and checks for a separate success state. No new recording or per-run approval is needed for this enabled workflow. The implementation checks freshness, source identity and destination identity, and stops if the new message is stale, missing or ambiguous. Browser tests exercise this flow on test pages. Real WhatsApp and university accounts still need validation.</a:t>
             </a:r>
             <a:endParaRPr lang="en-GB" sz="1200" b="0"/>
           </a:p>
@@ -1278,7 +1278,7 @@
                 <a:ea typeface="Segoe UI"/>
                 <a:cs typeface="Segoe UI"/>
               </a:rPr>
-              <a:t xml:space="preserve">The browser extension is JavaScript and handles recording plus browser actions. The desktop is C# with .NET 10 and WPF. An authenticated Kestrel loopback bridge connects it to the extension. The open-weight model is Google Gemma 4 E2B IT QAT Q4_0, running locally with llama.cpp on the CPU. It is an important part of the product: it interprets a demonstration, extracts changing values, resolves questions and matches task context. My application code supplies the recorder, prompts and workflow contracts, the compiler that binds observed controls, the fresh-code coordinator and the model runtime manager. Model weights and llama.cpp are upstream dependencies. This product uses local inference, not the Gemini API.</a:t>
+              <a:t xml:space="preserve">The JavaScript browser extension monitors page context and performs browser actions. The desktop is C# with .NET 10 and WPF. An authenticated Kestrel loopback bridge connects it to the extension. The open-weight model is Google Gemma 4 E2B IT QAT Q4_0, running locally with llama.cpp on the CPU. It interprets task evidence, extracts changing values, resolves questions and matches the current page to a learned workflow. My application code supplies the observation adapter, workflow contracts and compiler, page-trigger matching, fresh-code coordinator and runtime manager. Model weights and llama.cpp are upstream dependencies. This product uses local inference rather than the Gemini API.</a:t>
             </a:r>
             <a:endParaRPr lang="en-GB" sz="1200" b="0"/>
           </a:p>
@@ -1531,7 +1531,7 @@
                 <a:ea typeface="Segoe UI"/>
                 <a:cs typeface="Segoe UI"/>
               </a:rPr>
-              <a:t xml:space="preserve">The current implementation includes task recording, workflow review, local Gemma learning and saved workflow execution for supported actions. Fresh-code checks have browser-fixture coverage. That gives the idea a concrete implementation, but it does not establish real WhatsApp or university compatibility. The next steps are a complete acceptance run on those live accounts and the actual laptop, plus fixing the expanded saved-rule model QA failure. The original goal stays simple: spend less effort manually repeating a browser routine I already know. The repository contains the implementation and its tests. No time-saving or adoption metrics have been measured.</a:t>
+              <a:t xml:space="preserve">The current implementation includes page monitoring, local task matching and automatic execution of explicitly enabled learned verification workflows. Fresh-code checks have browser-fixture coverage. General background learning and automation remain the wider goal, rather than a completed capability for arbitrary browser work. Next comes real university and WhatsApp account testing, performance measurement on the actual laptop and resolving the remaining expanded workflow QA issues. The aim is to let Kopi handle routine work while I carry on. No time-saving or adoption metrics have been measured.</a:t>
             </a:r>
             <a:endParaRPr lang="en-GB" sz="1200" b="0"/>
           </a:p>
@@ -1766,7 +1766,7 @@
       </p:pic>
       <p:sp>
         <p:nvSpPr>
-          <p:cNvPr id="3" name="A local AI assistant that learns browser tasks from a d"/>
+          <p:cNvPr id="3" name="A local AI assistant that handles browser routines in t"/>
           <p:cNvSpPr txBox="1"/>
           <p:nvPr/>
         </p:nvSpPr>
@@ -1801,7 +1801,7 @@
                 <a:ea typeface="Segoe UI"/>
                 <a:cs typeface="Segoe UI"/>
               </a:rPr>
-              <a:t xml:space="preserve">A local AI assistant that learns</a:t>
+              <a:t xml:space="preserve">A local AI assistant that handles</a:t>
             </a:r>
             <a:endParaRPr lang="en-GB" sz="2550" b="0"/>
           </a:p>
@@ -1820,7 +1820,7 @@
                 <a:ea typeface="Segoe UI"/>
                 <a:cs typeface="Segoe UI"/>
               </a:rPr>
-              <a:t xml:space="preserve">browser tasks from a demonstration</a:t>
+              <a:t xml:space="preserve">browser routines in the background</a:t>
             </a:r>
             <a:endParaRPr lang="en-GB" sz="2550" b="0"/>
           </a:p>
@@ -2412,7 +2412,7 @@
       </p:sp>
       <p:sp>
         <p:nvSpPr>
-          <p:cNvPr id="4" name="What if I could show my browser a task once, and teach "/>
+          <p:cNvPr id="4" name="What if my computer recognised the routine and handled "/>
           <p:cNvSpPr txBox="1"/>
           <p:nvPr/>
         </p:nvSpPr>
@@ -2447,7 +2447,7 @@
                 <a:ea typeface="Segoe UI"/>
                 <a:cs typeface="Segoe UI"/>
               </a:rPr>
-              <a:t xml:space="preserve">What if I could show my browser</a:t>
+              <a:t xml:space="preserve">What if my computer recognised</a:t>
             </a:r>
             <a:endParaRPr lang="en-GB" sz="3675" b="1"/>
           </a:p>
@@ -2466,7 +2466,7 @@
                 <a:ea typeface="Segoe UI"/>
                 <a:cs typeface="Segoe UI"/>
               </a:rPr>
-              <a:t xml:space="preserve">a task once, and teach it</a:t>
+              <a:t xml:space="preserve">the routine and handled it</a:t>
             </a:r>
             <a:endParaRPr lang="en-GB" sz="3675" b="1"/>
           </a:p>
@@ -2485,7 +2485,7 @@
                 <a:ea typeface="Segoe UI"/>
                 <a:cs typeface="Segoe UI"/>
               </a:rPr>
-              <a:t xml:space="preserve">to repeat the routine?</a:t>
+              <a:t xml:space="preserve">while I carried on?</a:t>
             </a:r>
             <a:endParaRPr lang="en-GB" sz="3675" b="1"/>
           </a:p>
@@ -2674,7 +2674,7 @@
       </p:sp>
       <p:sp>
         <p:nvSpPr>
-          <p:cNvPr id="4" name="Observe"/>
+          <p:cNvPr id="4" name="Watch"/>
           <p:cNvSpPr txBox="1"/>
           <p:nvPr/>
         </p:nvSpPr>
@@ -2709,7 +2709,7 @@
                 <a:ea typeface="Segoe UI"/>
                 <a:cs typeface="Segoe UI"/>
               </a:rPr>
-              <a:t xml:space="preserve">Observe</a:t>
+              <a:t xml:space="preserve">Watch</a:t>
             </a:r>
             <a:endParaRPr lang="en-GB" sz="2400" b="1"/>
           </a:p>
@@ -2717,7 +2717,7 @@
       </p:sp>
       <p:sp>
         <p:nvSpPr>
-          <p:cNvPr id="5" name="Record a task in the browser I already use."/>
+          <p:cNvPr id="5" name="Notice page context while Kopi runs in the background."/>
           <p:cNvSpPr txBox="1"/>
           <p:nvPr/>
         </p:nvSpPr>
@@ -2752,7 +2752,7 @@
                 <a:ea typeface="Segoe UI"/>
                 <a:cs typeface="Segoe UI"/>
               </a:rPr>
-              <a:t xml:space="preserve">Record a task in the browser I already use.</a:t>
+              <a:t xml:space="preserve">Notice page context while Kopi runs in the background.</a:t>
             </a:r>
             <a:endParaRPr lang="en-GB" sz="2100" b="0"/>
           </a:p>
@@ -2825,7 +2825,7 @@
       </p:sp>
       <p:sp>
         <p:nvSpPr>
-          <p:cNvPr id="8" name="Learn"/>
+          <p:cNvPr id="8" name="Recognise"/>
           <p:cNvSpPr txBox="1"/>
           <p:nvPr/>
         </p:nvSpPr>
@@ -2860,7 +2860,7 @@
                 <a:ea typeface="Segoe UI"/>
                 <a:cs typeface="Segoe UI"/>
               </a:rPr>
-              <a:t xml:space="preserve">Learn</a:t>
+              <a:t xml:space="preserve">Recognise</a:t>
             </a:r>
             <a:endParaRPr lang="en-GB" sz="2400" b="1"/>
           </a:p>
@@ -2868,7 +2868,7 @@
       </p:sp>
       <p:sp>
         <p:nvSpPr>
-          <p:cNvPr id="9" name="Gemma identifies the steps and changing inputs."/>
+          <p:cNvPr id="9" name="Match the current task to a learned routine with Gemma."/>
           <p:cNvSpPr txBox="1"/>
           <p:nvPr/>
         </p:nvSpPr>
@@ -2903,7 +2903,7 @@
                 <a:ea typeface="Segoe UI"/>
                 <a:cs typeface="Segoe UI"/>
               </a:rPr>
-              <a:t xml:space="preserve">Gemma identifies the steps and changing inputs.</a:t>
+              <a:t xml:space="preserve">Match the current task to a learned routine with Gemma.</a:t>
             </a:r>
             <a:endParaRPr lang="en-GB" sz="2100" b="0"/>
           </a:p>
@@ -2976,7 +2976,7 @@
       </p:sp>
       <p:sp>
         <p:nvSpPr>
-          <p:cNvPr id="12" name="Review"/>
+          <p:cNvPr id="12" name="Act"/>
           <p:cNvSpPr txBox="1"/>
           <p:nvPr/>
         </p:nvSpPr>
@@ -3011,7 +3011,7 @@
                 <a:ea typeface="Segoe UI"/>
                 <a:cs typeface="Segoe UI"/>
               </a:rPr>
-              <a:t xml:space="preserve">Review</a:t>
+              <a:t xml:space="preserve">Act</a:t>
             </a:r>
             <a:endParaRPr lang="en-GB" sz="2400" b="1"/>
           </a:p>
@@ -3019,7 +3019,7 @@
       </p:sp>
       <p:sp>
         <p:nvSpPr>
-          <p:cNvPr id="13" name="Resolve missing details and save the workflow."/>
+          <p:cNvPr id="13" name="Run an enabled verification workflow automatically."/>
           <p:cNvSpPr txBox="1"/>
           <p:nvPr/>
         </p:nvSpPr>
@@ -3054,7 +3054,7 @@
                 <a:ea typeface="Segoe UI"/>
                 <a:cs typeface="Segoe UI"/>
               </a:rPr>
-              <a:t xml:space="preserve">Resolve missing details and save the workflow.</a:t>
+              <a:t xml:space="preserve">Run an enabled verification workflow automatically.</a:t>
             </a:r>
             <a:endParaRPr lang="en-GB" sz="2100" b="0"/>
           </a:p>
@@ -3127,7 +3127,7 @@
       </p:sp>
       <p:sp>
         <p:nvSpPr>
-          <p:cNvPr id="16" name="Repeat"/>
+          <p:cNvPr id="16" name="Check"/>
           <p:cNvSpPr txBox="1"/>
           <p:nvPr/>
         </p:nvSpPr>
@@ -3162,7 +3162,7 @@
                 <a:ea typeface="Segoe UI"/>
                 <a:cs typeface="Segoe UI"/>
               </a:rPr>
-              <a:t xml:space="preserve">Repeat</a:t>
+              <a:t xml:space="preserve">Check</a:t>
             </a:r>
             <a:endParaRPr lang="en-GB" sz="2400" b="1"/>
           </a:p>
@@ -3170,7 +3170,7 @@
       </p:sp>
       <p:sp>
         <p:nvSpPr>
-          <p:cNvPr id="17" name="Run the saved routine with fresh information."/>
+          <p:cNvPr id="17" name="Confirm the result and stop if anything is uncertain."/>
           <p:cNvSpPr txBox="1"/>
           <p:nvPr/>
         </p:nvSpPr>
@@ -3205,7 +3205,7 @@
                 <a:ea typeface="Segoe UI"/>
                 <a:cs typeface="Segoe UI"/>
               </a:rPr>
-              <a:t xml:space="preserve">Run the saved routine with fresh information.</a:t>
+              <a:t xml:space="preserve">Confirm the result and stop if anything is uncertain.</a:t>
             </a:r>
             <a:endParaRPr lang="en-GB" sz="2100" b="0"/>
           </a:p>
@@ -3376,7 +3376,7 @@
       </p:sp>
       <p:sp>
         <p:nvSpPr>
-          <p:cNvPr id="5" name="Request"/>
+          <p:cNvPr id="5" name="Detect"/>
           <p:cNvSpPr txBox="1"/>
           <p:nvPr/>
         </p:nvSpPr>
@@ -3411,7 +3411,7 @@
                 <a:ea typeface="Segoe UI"/>
                 <a:cs typeface="Segoe UI"/>
               </a:rPr>
-              <a:t xml:space="preserve">Request</a:t>
+              <a:t xml:space="preserve">Detect</a:t>
             </a:r>
             <a:endParaRPr lang="en-GB" sz="2925" b="1"/>
           </a:p>
@@ -3419,7 +3419,7 @@
       </p:sp>
       <p:sp>
         <p:nvSpPr>
-          <p:cNvPr id="6" name="A new challenge asks for a fresh code."/>
+          <p:cNvPr id="6" name="Recognise a matching new sign-in challenge."/>
           <p:cNvSpPr txBox="1"/>
           <p:nvPr/>
         </p:nvSpPr>
@@ -3454,7 +3454,7 @@
                 <a:ea typeface="Segoe UI"/>
                 <a:cs typeface="Segoe UI"/>
               </a:rPr>
-              <a:t xml:space="preserve">A new challenge asks</a:t>
+              <a:t xml:space="preserve">Recognise a matching</a:t>
             </a:r>
             <a:endParaRPr lang="en-GB" sz="2175" b="0"/>
           </a:p>
@@ -3473,7 +3473,7 @@
                 <a:ea typeface="Segoe UI"/>
                 <a:cs typeface="Segoe UI"/>
               </a:rPr>
-              <a:t xml:space="preserve">for a fresh code.</a:t>
+              <a:t xml:space="preserve">new sign-in challenge.</a:t>
             </a:r>
             <a:endParaRPr lang="en-GB" sz="2175" b="0"/>
           </a:p>
@@ -3546,7 +3546,7 @@
       </p:sp>
       <p:sp>
         <p:nvSpPr>
-          <p:cNvPr id="9" name="Read"/>
+          <p:cNvPr id="9" name="Fetch"/>
           <p:cNvSpPr txBox="1"/>
           <p:nvPr/>
         </p:nvSpPr>
@@ -3581,7 +3581,7 @@
                 <a:ea typeface="Segoe UI"/>
                 <a:cs typeface="Segoe UI"/>
               </a:rPr>
-              <a:t xml:space="preserve">Read</a:t>
+              <a:t xml:space="preserve">Fetch</a:t>
             </a:r>
             <a:endParaRPr lang="en-GB" sz="2925" b="1"/>
           </a:p>
@@ -3589,7 +3589,7 @@
       </p:sp>
       <p:sp>
         <p:nvSpPr>
-          <p:cNvPr id="10" name="Find the new code in the correct conversation."/>
+          <p:cNvPr id="10" name="Request a code and read the new matching message."/>
           <p:cNvSpPr txBox="1"/>
           <p:nvPr/>
         </p:nvSpPr>
@@ -3624,7 +3624,7 @@
                 <a:ea typeface="Segoe UI"/>
                 <a:cs typeface="Segoe UI"/>
               </a:rPr>
-              <a:t xml:space="preserve">Find the new code in</a:t>
+              <a:t xml:space="preserve">Request a code and read</a:t>
             </a:r>
             <a:endParaRPr lang="en-GB" sz="2175" b="0"/>
           </a:p>
@@ -3643,7 +3643,7 @@
                 <a:ea typeface="Segoe UI"/>
                 <a:cs typeface="Segoe UI"/>
               </a:rPr>
-              <a:t xml:space="preserve">the correct conversation.</a:t>
+              <a:t xml:space="preserve">the new matching message.</a:t>
             </a:r>
             <a:endParaRPr lang="en-GB" sz="2175" b="0"/>
           </a:p>
@@ -3759,7 +3759,7 @@
       </p:sp>
       <p:sp>
         <p:nvSpPr>
-          <p:cNvPr id="14" name="Enter it, submit and check the result."/>
+          <p:cNvPr id="14" name="Fill, submit and check the result automatically."/>
           <p:cNvSpPr txBox="1"/>
           <p:nvPr/>
         </p:nvSpPr>
@@ -3794,7 +3794,7 @@
                 <a:ea typeface="Segoe UI"/>
                 <a:cs typeface="Segoe UI"/>
               </a:rPr>
-              <a:t xml:space="preserve">Enter it, submit and</a:t>
+              <a:t xml:space="preserve">Fill, submit and check</a:t>
             </a:r>
             <a:endParaRPr lang="en-GB" sz="2175" b="0"/>
           </a:p>
@@ -3813,7 +3813,7 @@
                 <a:ea typeface="Segoe UI"/>
                 <a:cs typeface="Segoe UI"/>
               </a:rPr>
-              <a:t xml:space="preserve">check the result.</a:t>
+              <a:t xml:space="preserve">the result automatically.</a:t>
             </a:r>
             <a:endParaRPr lang="en-GB" sz="2175" b="0"/>
           </a:p>
@@ -4397,7 +4397,7 @@
       </p:sp>
       <p:sp>
         <p:nvSpPr>
-          <p:cNvPr id="5" name="JavaScript Records and acts"/>
+          <p:cNvPr id="5" name="JavaScript Monitors and acts"/>
           <p:cNvSpPr txBox="1"/>
           <p:nvPr/>
         </p:nvSpPr>
@@ -4451,7 +4451,7 @@
                 <a:ea typeface="Segoe UI"/>
                 <a:cs typeface="Segoe UI"/>
               </a:rPr>
-              <a:t xml:space="preserve">Records and acts</a:t>
+              <a:t xml:space="preserve">Monitors and acts</a:t>
             </a:r>
             <a:endParaRPr lang="en-GB" sz="1725" b="0"/>
           </a:p>
@@ -4524,7 +4524,7 @@
       </p:sp>
       <p:sp>
         <p:nvSpPr>
-          <p:cNvPr id="8" name="C# / .NET 10 / WPF Reviews and validates"/>
+          <p:cNvPr id="8" name="C# / .NET 10 / WPF Coordinates and validates"/>
           <p:cNvSpPr txBox="1"/>
           <p:nvPr/>
         </p:nvSpPr>
@@ -4578,7 +4578,7 @@
                 <a:ea typeface="Segoe UI"/>
                 <a:cs typeface="Segoe UI"/>
               </a:rPr>
-              <a:t xml:space="preserve">Reviews and validates</a:t>
+              <a:t xml:space="preserve">Coordinates and validates</a:t>
             </a:r>
             <a:endParaRPr lang="en-GB" sz="1725" b="0"/>
           </a:p>
@@ -4757,7 +4757,7 @@
       </p:sp>
       <p:sp>
         <p:nvSpPr>
-          <p:cNvPr id="14" name="Gemma understands the demonstration and separates fixed"/>
+          <p:cNvPr id="14" name="Gemma recognises the task context and matches it to a l"/>
           <p:cNvSpPr txBox="1"/>
           <p:nvPr/>
         </p:nvSpPr>
@@ -4792,7 +4792,7 @@
                 <a:ea typeface="Segoe UI"/>
                 <a:cs typeface="Segoe UI"/>
               </a:rPr>
-              <a:t xml:space="preserve">Gemma understands the demonstration</a:t>
+              <a:t xml:space="preserve">Gemma recognises the task context</a:t>
             </a:r>
             <a:endParaRPr lang="en-GB" sz="2475" b="1"/>
           </a:p>
@@ -4811,7 +4811,7 @@
                 <a:ea typeface="Segoe UI"/>
                 <a:cs typeface="Segoe UI"/>
               </a:rPr>
-              <a:t xml:space="preserve">and separates fixed steps from new inputs.</a:t>
+              <a:t xml:space="preserve">and matches it to a learned workflow.</a:t>
             </a:r>
             <a:endParaRPr lang="en-GB" sz="2475" b="1"/>
           </a:p>
@@ -4819,7 +4819,7 @@
       </p:sp>
       <p:sp>
         <p:nvSpPr>
-          <p:cNvPr id="15" name="I built the recorder, workflow compiler, code-transfer "/>
+          <p:cNvPr id="15" name="I built the page triggers, workflow compiler, code-tran"/>
           <p:cNvSpPr txBox="1"/>
           <p:nvPr/>
         </p:nvSpPr>
@@ -4854,7 +4854,7 @@
                 <a:ea typeface="Segoe UI"/>
                 <a:cs typeface="Segoe UI"/>
               </a:rPr>
-              <a:t xml:space="preserve">I built the recorder, workflow compiler, code-transfer logic and runtime manager.</a:t>
+              <a:t xml:space="preserve">I built the page triggers, workflow compiler, code-transfer logic and runtime manager.</a:t>
             </a:r>
             <a:endParaRPr lang="en-GB" sz="2025" b="0"/>
           </a:p>
@@ -4981,7 +4981,7 @@
       </p:sp>
       <p:sp>
         <p:nvSpPr>
-          <p:cNvPr id="4" name="Task recording and workflow review Learning with local "/>
+          <p:cNvPr id="4" name="Page monitoring and local matching Automatic enabled ve"/>
           <p:cNvSpPr txBox="1"/>
           <p:nvPr/>
         </p:nvSpPr>
@@ -5016,7 +5016,7 @@
                 <a:ea typeface="Segoe UI"/>
                 <a:cs typeface="Segoe UI"/>
               </a:rPr>
-              <a:t xml:space="preserve">Task recording and workflow review</a:t>
+              <a:t xml:space="preserve">Page monitoring and local matching</a:t>
             </a:r>
             <a:endParaRPr lang="en-GB" sz="2100" b="0"/>
           </a:p>
@@ -5035,7 +5035,7 @@
                 <a:ea typeface="Segoe UI"/>
                 <a:cs typeface="Segoe UI"/>
               </a:rPr>
-              <a:t xml:space="preserve">Learning with local Gemma</a:t>
+              <a:t xml:space="preserve">Automatic enabled verification runs</a:t>
             </a:r>
             <a:endParaRPr lang="en-GB" sz="2100" b="0"/>
           </a:p>
@@ -5054,7 +5054,7 @@
                 <a:ea typeface="Segoe UI"/>
                 <a:cs typeface="Segoe UI"/>
               </a:rPr>
-              <a:t xml:space="preserve">Saved workflow execution</a:t>
+              <a:t xml:space="preserve">Local Gemma task understanding</a:t>
             </a:r>
             <a:endParaRPr lang="en-GB" sz="2100" b="0"/>
           </a:p>
@@ -5124,7 +5124,7 @@
       </p:sp>
       <p:sp>
         <p:nvSpPr>
-          <p:cNvPr id="6" name="Test real university and WhatsApp flows Measure perform"/>
+          <p:cNvPr id="6" name="Broaden background learning and automation Test real un"/>
           <p:cNvSpPr txBox="1"/>
           <p:nvPr/>
         </p:nvSpPr>
@@ -5144,6 +5144,25 @@
         <p:txBody>
           <a:bodyPr wrap="square" lIns="0" tIns="0" rIns="0" bIns="0" anchor="t"/>
           <a:lstStyle/>
+          <a:p>
+            <a:pPr algn="l">
+              <a:lnSpc>
+                <a:spcPct val="110000"/>
+              </a:lnSpc>
+            </a:pPr>
+            <a:r>
+              <a:rPr lang="en-GB" sz="2100" b="0">
+                <a:solidFill>
+                  <a:srgbClr val="201D1D"/>
+                </a:solidFill>
+                <a:latin typeface="Segoe UI"/>
+                <a:ea typeface="Segoe UI"/>
+                <a:cs typeface="Segoe UI"/>
+              </a:rPr>
+              <a:t xml:space="preserve">Broaden background learning and automation</a:t>
+            </a:r>
+            <a:endParaRPr lang="en-GB" sz="2100" b="0"/>
+          </a:p>
           <a:p>
             <a:pPr algn="l">
               <a:lnSpc>

</xml_diff>